<commit_message>
Created the final version without AI
</commit_message>
<xml_diff>
--- a/Hackaton Log.pptx
+++ b/Hackaton Log.pptx
@@ -5,10 +5,14 @@
     <p:sldMasterId id="2147483648" r:id="rId1"/>
   </p:sldMasterIdLst>
   <p:notesMasterIdLst>
-    <p:notesMasterId r:id="rId3"/>
+    <p:notesMasterId r:id="rId7"/>
   </p:notesMasterIdLst>
   <p:sldIdLst>
     <p:sldId id="256" r:id="rId2"/>
+    <p:sldId id="257" r:id="rId3"/>
+    <p:sldId id="258" r:id="rId4"/>
+    <p:sldId id="259" r:id="rId5"/>
+    <p:sldId id="260" r:id="rId6"/>
   </p:sldIdLst>
   <p:sldSz cx="12192000" cy="6858000"/>
   <p:notesSz cx="6858000" cy="9144000"/>
@@ -107,6 +111,11 @@
       </a:defRPr>
     </a:lvl9pPr>
   </p:defaultTextStyle>
+  <p:extLst>
+    <p:ext uri="{EFAFB233-063F-42B5-8137-9DF3F51BA10A}">
+      <p15:sldGuideLst xmlns:p15="http://schemas.microsoft.com/office/powerpoint/2012/main"/>
+    </p:ext>
+  </p:extLst>
 </p:presentation>
 </file>
 
@@ -1692,7 +1701,7 @@
               </a:defRPr>
             </a:pPr>
             <a:r>
-              <a:rPr sz="3900" b="1" dirty="0">
+              <a:rPr lang="en-US" sz="3900" b="1" dirty="0" err="1">
                 <a:solidFill>
                   <a:srgbClr val="08285C"/>
                 </a:solidFill>
@@ -1700,8 +1709,27 @@
                 <a:ea typeface="Bahnschrift"/>
                 <a:cs typeface="Bahnschrift"/>
               </a:rPr>
-              <a:t>TITLE</a:t>
+              <a:t>TechJam</a:t>
             </a:r>
+            <a:r>
+              <a:rPr lang="en-US" sz="3900" b="1" dirty="0">
+                <a:solidFill>
+                  <a:srgbClr val="08285C"/>
+                </a:solidFill>
+                <a:latin typeface="Bahnschrift"/>
+                <a:ea typeface="Bahnschrift"/>
+                <a:cs typeface="Bahnschrift"/>
+              </a:rPr>
+              <a:t> Track 4</a:t>
+            </a:r>
+            <a:endParaRPr sz="3900" b="1" dirty="0">
+              <a:solidFill>
+                <a:srgbClr val="08285C"/>
+              </a:solidFill>
+              <a:latin typeface="Bahnschrift"/>
+              <a:ea typeface="Bahnschrift"/>
+              <a:cs typeface="Bahnschrift"/>
+            </a:endParaRPr>
           </a:p>
         </p:txBody>
       </p:sp>
@@ -1748,7 +1776,7 @@
               </a:defRPr>
             </a:pPr>
             <a:r>
-              <a:rPr sz="1725" b="0" dirty="0">
+              <a:rPr lang="en-US" sz="1725" dirty="0">
                 <a:solidFill>
                   <a:srgbClr val="375C86"/>
                 </a:solidFill>
@@ -1756,8 +1784,16 @@
                 <a:ea typeface="Arial"/>
                 <a:cs typeface="Arial"/>
               </a:rPr>
-              <a:t>SUBTITLE</a:t>
+              <a:t>Bryan Ang</a:t>
             </a:r>
+            <a:endParaRPr sz="1725" b="0" dirty="0">
+              <a:solidFill>
+                <a:srgbClr val="375C86"/>
+              </a:solidFill>
+              <a:latin typeface="Arial"/>
+              <a:ea typeface="Arial"/>
+              <a:cs typeface="Arial"/>
+            </a:endParaRPr>
           </a:p>
         </p:txBody>
       </p:sp>
@@ -1803,6 +1839,518 @@
     <p:extLst>
       <p:ext uri="{BB962C8B-B14F-4D97-AF65-F5344CB8AC3E}">
         <p14:creationId xmlns:p14="http://schemas.microsoft.com/office/powerpoint/2010/main" val="535950200"/>
+      </p:ext>
+    </p:extLst>
+  </p:cSld>
+  <p:clrMapOvr>
+    <a:masterClrMapping/>
+  </p:clrMapOvr>
+</p:sld>
+</file>
+
+<file path=ppt/slides/slide2.xml><?xml version="1.0" encoding="utf-8"?>
+<p:sld xmlns:a="http://schemas.openxmlformats.org/drawingml/2006/main" xmlns:r="http://schemas.openxmlformats.org/officeDocument/2006/relationships" xmlns:p="http://schemas.openxmlformats.org/presentationml/2006/main">
+  <p:cSld>
+    <p:spTree>
+      <p:nvGrpSpPr>
+        <p:cNvPr id="1" name=""/>
+        <p:cNvGrpSpPr/>
+        <p:nvPr/>
+      </p:nvGrpSpPr>
+      <p:grpSpPr>
+        <a:xfrm>
+          <a:off x="0" y="0"/>
+          <a:ext cx="0" cy="0"/>
+          <a:chOff x="0" y="0"/>
+          <a:chExt cx="0" cy="0"/>
+        </a:xfrm>
+      </p:grpSpPr>
+      <p:sp>
+        <p:nvSpPr>
+          <p:cNvPr id="2" name="Text Placeholder 1">
+            <a:extLst>
+              <a:ext uri="{FF2B5EF4-FFF2-40B4-BE49-F238E27FC236}">
+                <a16:creationId xmlns:a16="http://schemas.microsoft.com/office/drawing/2014/main" id="{131E9609-AAB5-554D-D1F3-E7A05EA5B666}"/>
+              </a:ext>
+            </a:extLst>
+          </p:cNvPr>
+          <p:cNvSpPr>
+            <a:spLocks noGrp="1"/>
+          </p:cNvSpPr>
+          <p:nvPr>
+            <p:ph type="body" sz="quarter" idx="10"/>
+          </p:nvPr>
+        </p:nvSpPr>
+        <p:spPr>
+          <a:xfrm>
+            <a:off x="857250" y="633413"/>
+            <a:ext cx="9139604" cy="554037"/>
+          </a:xfrm>
+        </p:spPr>
+        <p:txBody>
+          <a:bodyPr/>
+          <a:lstStyle/>
+          <a:p>
+            <a:r>
+              <a:rPr lang="en-US" dirty="0"/>
+              <a:t>Day 0-Analysis of original BM25</a:t>
+            </a:r>
+          </a:p>
+        </p:txBody>
+      </p:sp>
+      <p:sp>
+        <p:nvSpPr>
+          <p:cNvPr id="3" name="Text Placeholder 2">
+            <a:extLst>
+              <a:ext uri="{FF2B5EF4-FFF2-40B4-BE49-F238E27FC236}">
+                <a16:creationId xmlns:a16="http://schemas.microsoft.com/office/drawing/2014/main" id="{44E5A330-76FC-DD26-DE83-F330F469608B}"/>
+              </a:ext>
+            </a:extLst>
+          </p:cNvPr>
+          <p:cNvSpPr>
+            <a:spLocks noGrp="1"/>
+          </p:cNvSpPr>
+          <p:nvPr>
+            <p:ph type="body" sz="quarter" idx="11"/>
+          </p:nvPr>
+        </p:nvSpPr>
+        <p:spPr/>
+        <p:txBody>
+          <a:bodyPr/>
+          <a:lstStyle/>
+          <a:p>
+            <a:r>
+              <a:rPr lang="en-US" dirty="0"/>
+              <a:t>Original Agent</a:t>
+            </a:r>
+          </a:p>
+          <a:p>
+            <a:r>
+              <a:rPr lang="en-US" dirty="0"/>
+              <a:t>Uses OR for keyword matching</a:t>
+            </a:r>
+          </a:p>
+          <a:p>
+            <a:r>
+              <a:rPr lang="en-US" dirty="0"/>
+              <a:t>Does not have memory</a:t>
+            </a:r>
+          </a:p>
+          <a:p>
+            <a:r>
+              <a:rPr lang="en-US" dirty="0"/>
+              <a:t>Does not request for information from the user</a:t>
+            </a:r>
+          </a:p>
+          <a:p>
+            <a:endParaRPr lang="en-US" dirty="0"/>
+          </a:p>
+        </p:txBody>
+      </p:sp>
+    </p:spTree>
+    <p:extLst>
+      <p:ext uri="{BB962C8B-B14F-4D97-AF65-F5344CB8AC3E}">
+        <p14:creationId xmlns:p14="http://schemas.microsoft.com/office/powerpoint/2010/main" val="4170898410"/>
+      </p:ext>
+    </p:extLst>
+  </p:cSld>
+  <p:clrMapOvr>
+    <a:masterClrMapping/>
+  </p:clrMapOvr>
+</p:sld>
+</file>
+
+<file path=ppt/slides/slide3.xml><?xml version="1.0" encoding="utf-8"?>
+<p:sld xmlns:a="http://schemas.openxmlformats.org/drawingml/2006/main" xmlns:r="http://schemas.openxmlformats.org/officeDocument/2006/relationships" xmlns:p="http://schemas.openxmlformats.org/presentationml/2006/main">
+  <p:cSld>
+    <p:spTree>
+      <p:nvGrpSpPr>
+        <p:cNvPr id="1" name="">
+          <a:extLst>
+            <a:ext uri="{FF2B5EF4-FFF2-40B4-BE49-F238E27FC236}">
+              <a16:creationId xmlns:a16="http://schemas.microsoft.com/office/drawing/2014/main" id="{FD3186C7-FFE0-8A56-2459-6A927C163735}"/>
+            </a:ext>
+          </a:extLst>
+        </p:cNvPr>
+        <p:cNvGrpSpPr/>
+        <p:nvPr/>
+      </p:nvGrpSpPr>
+      <p:grpSpPr>
+        <a:xfrm>
+          <a:off x="0" y="0"/>
+          <a:ext cx="0" cy="0"/>
+          <a:chOff x="0" y="0"/>
+          <a:chExt cx="0" cy="0"/>
+        </a:xfrm>
+      </p:grpSpPr>
+      <p:sp>
+        <p:nvSpPr>
+          <p:cNvPr id="2" name="Text Placeholder 1">
+            <a:extLst>
+              <a:ext uri="{FF2B5EF4-FFF2-40B4-BE49-F238E27FC236}">
+                <a16:creationId xmlns:a16="http://schemas.microsoft.com/office/drawing/2014/main" id="{CCDCCDB2-09AB-C17F-7D61-B500C57F98A6}"/>
+              </a:ext>
+            </a:extLst>
+          </p:cNvPr>
+          <p:cNvSpPr>
+            <a:spLocks noGrp="1"/>
+          </p:cNvSpPr>
+          <p:nvPr>
+            <p:ph type="body" sz="quarter" idx="10"/>
+          </p:nvPr>
+        </p:nvSpPr>
+        <p:spPr>
+          <a:xfrm>
+            <a:off x="857250" y="633413"/>
+            <a:ext cx="9139604" cy="554037"/>
+          </a:xfrm>
+        </p:spPr>
+        <p:txBody>
+          <a:bodyPr/>
+          <a:lstStyle/>
+          <a:p>
+            <a:r>
+              <a:rPr lang="en-US" dirty="0"/>
+              <a:t>Day 1-Planning for the </a:t>
+            </a:r>
+            <a:r>
+              <a:rPr lang="en-US" dirty="0" err="1"/>
+              <a:t>Hackaton</a:t>
+            </a:r>
+            <a:endParaRPr lang="en-US" dirty="0"/>
+          </a:p>
+        </p:txBody>
+      </p:sp>
+      <p:sp>
+        <p:nvSpPr>
+          <p:cNvPr id="3" name="Text Placeholder 2">
+            <a:extLst>
+              <a:ext uri="{FF2B5EF4-FFF2-40B4-BE49-F238E27FC236}">
+                <a16:creationId xmlns:a16="http://schemas.microsoft.com/office/drawing/2014/main" id="{A5BCB580-71E6-140B-2EEA-11C751D9A760}"/>
+              </a:ext>
+            </a:extLst>
+          </p:cNvPr>
+          <p:cNvSpPr>
+            <a:spLocks noGrp="1"/>
+          </p:cNvSpPr>
+          <p:nvPr>
+            <p:ph type="body" sz="quarter" idx="11"/>
+          </p:nvPr>
+        </p:nvSpPr>
+        <p:spPr/>
+        <p:txBody>
+          <a:bodyPr/>
+          <a:lstStyle/>
+          <a:p>
+            <a:pPr marL="514350" indent="-514350">
+              <a:buFont typeface="Arial" panose="020B0604020202020204" pitchFamily="34" charset="0"/>
+              <a:buChar char="•"/>
+            </a:pPr>
+            <a:r>
+              <a:rPr lang="en-US" dirty="0"/>
+              <a:t>Improve upon the original agent</a:t>
+            </a:r>
+          </a:p>
+          <a:p>
+            <a:pPr marL="971550" lvl="1" indent="-514350">
+              <a:buFont typeface="Arial" panose="020B0604020202020204" pitchFamily="34" charset="0"/>
+              <a:buChar char="•"/>
+            </a:pPr>
+            <a:r>
+              <a:rPr lang="en-US" dirty="0"/>
+              <a:t>Use AND instead of OR</a:t>
+            </a:r>
+          </a:p>
+          <a:p>
+            <a:pPr marL="971550" lvl="1" indent="-514350">
+              <a:buFont typeface="Arial" panose="020B0604020202020204" pitchFamily="34" charset="0"/>
+              <a:buChar char="•"/>
+            </a:pPr>
+            <a:r>
+              <a:rPr lang="en-US" dirty="0"/>
+              <a:t>Ask  questions to the user</a:t>
+            </a:r>
+          </a:p>
+          <a:p>
+            <a:pPr marL="971550" lvl="1" indent="-514350">
+              <a:buFont typeface="Arial" panose="020B0604020202020204" pitchFamily="34" charset="0"/>
+              <a:buChar char="•"/>
+            </a:pPr>
+            <a:r>
+              <a:rPr lang="en-US" dirty="0"/>
+              <a:t>Confirm the approach works</a:t>
+            </a:r>
+          </a:p>
+        </p:txBody>
+      </p:sp>
+    </p:spTree>
+    <p:extLst>
+      <p:ext uri="{BB962C8B-B14F-4D97-AF65-F5344CB8AC3E}">
+        <p14:creationId xmlns:p14="http://schemas.microsoft.com/office/powerpoint/2010/main" val="75685622"/>
+      </p:ext>
+    </p:extLst>
+  </p:cSld>
+  <p:clrMapOvr>
+    <a:masterClrMapping/>
+  </p:clrMapOvr>
+</p:sld>
+</file>
+
+<file path=ppt/slides/slide4.xml><?xml version="1.0" encoding="utf-8"?>
+<p:sld xmlns:a="http://schemas.openxmlformats.org/drawingml/2006/main" xmlns:r="http://schemas.openxmlformats.org/officeDocument/2006/relationships" xmlns:p="http://schemas.openxmlformats.org/presentationml/2006/main">
+  <p:cSld>
+    <p:spTree>
+      <p:nvGrpSpPr>
+        <p:cNvPr id="1" name="">
+          <a:extLst>
+            <a:ext uri="{FF2B5EF4-FFF2-40B4-BE49-F238E27FC236}">
+              <a16:creationId xmlns:a16="http://schemas.microsoft.com/office/drawing/2014/main" id="{35C6AEB3-B427-6F0B-2108-95664AFB54D7}"/>
+            </a:ext>
+          </a:extLst>
+        </p:cNvPr>
+        <p:cNvGrpSpPr/>
+        <p:nvPr/>
+      </p:nvGrpSpPr>
+      <p:grpSpPr>
+        <a:xfrm>
+          <a:off x="0" y="0"/>
+          <a:ext cx="0" cy="0"/>
+          <a:chOff x="0" y="0"/>
+          <a:chExt cx="0" cy="0"/>
+        </a:xfrm>
+      </p:grpSpPr>
+      <p:sp>
+        <p:nvSpPr>
+          <p:cNvPr id="2" name="Text Placeholder 1">
+            <a:extLst>
+              <a:ext uri="{FF2B5EF4-FFF2-40B4-BE49-F238E27FC236}">
+                <a16:creationId xmlns:a16="http://schemas.microsoft.com/office/drawing/2014/main" id="{D1FD1DFC-E093-F247-6ED2-C285E71C2042}"/>
+              </a:ext>
+            </a:extLst>
+          </p:cNvPr>
+          <p:cNvSpPr>
+            <a:spLocks noGrp="1"/>
+          </p:cNvSpPr>
+          <p:nvPr>
+            <p:ph type="body" sz="quarter" idx="10"/>
+          </p:nvPr>
+        </p:nvSpPr>
+        <p:spPr>
+          <a:xfrm>
+            <a:off x="857250" y="633413"/>
+            <a:ext cx="9139604" cy="554037"/>
+          </a:xfrm>
+        </p:spPr>
+        <p:txBody>
+          <a:bodyPr/>
+          <a:lstStyle/>
+          <a:p>
+            <a:r>
+              <a:rPr lang="en-US" dirty="0"/>
+              <a:t>Day 1 V1</a:t>
+            </a:r>
+          </a:p>
+        </p:txBody>
+      </p:sp>
+      <p:sp>
+        <p:nvSpPr>
+          <p:cNvPr id="3" name="Text Placeholder 2">
+            <a:extLst>
+              <a:ext uri="{FF2B5EF4-FFF2-40B4-BE49-F238E27FC236}">
+                <a16:creationId xmlns:a16="http://schemas.microsoft.com/office/drawing/2014/main" id="{0BFCA179-36BA-E5E8-C1CE-470D66CF588D}"/>
+              </a:ext>
+            </a:extLst>
+          </p:cNvPr>
+          <p:cNvSpPr>
+            <a:spLocks noGrp="1"/>
+          </p:cNvSpPr>
+          <p:nvPr>
+            <p:ph type="body" sz="quarter" idx="11"/>
+          </p:nvPr>
+        </p:nvSpPr>
+        <p:spPr/>
+        <p:txBody>
+          <a:bodyPr/>
+          <a:lstStyle/>
+          <a:p>
+            <a:pPr marL="514350" indent="-514350">
+              <a:buFont typeface="Arial" panose="020B0604020202020204" pitchFamily="34" charset="0"/>
+              <a:buChar char="•"/>
+            </a:pPr>
+            <a:r>
+              <a:rPr lang="en-US" dirty="0"/>
+              <a:t>Version 1 of agent</a:t>
+            </a:r>
+          </a:p>
+          <a:p>
+            <a:pPr marL="514350" indent="-514350">
+              <a:buFont typeface="Arial" panose="020B0604020202020204" pitchFamily="34" charset="0"/>
+              <a:buChar char="•"/>
+            </a:pPr>
+            <a:r>
+              <a:rPr lang="en-US" dirty="0"/>
+              <a:t>Ask question based on a hardcoded order</a:t>
+            </a:r>
+          </a:p>
+          <a:p>
+            <a:pPr marL="514350" indent="-514350">
+              <a:buFont typeface="Arial" panose="020B0604020202020204" pitchFamily="34" charset="0"/>
+              <a:buChar char="•"/>
+            </a:pPr>
+            <a:r>
+              <a:rPr lang="en-US" dirty="0"/>
+              <a:t>If the customer have no preference for bucket X&lt; it is skipped forever.</a:t>
+            </a:r>
+          </a:p>
+          <a:p>
+            <a:pPr marL="514350" indent="-514350">
+              <a:buFont typeface="Arial" panose="020B0604020202020204" pitchFamily="34" charset="0"/>
+              <a:buChar char="•"/>
+            </a:pPr>
+            <a:endParaRPr lang="en-US" dirty="0"/>
+          </a:p>
+        </p:txBody>
+      </p:sp>
+    </p:spTree>
+    <p:extLst>
+      <p:ext uri="{BB962C8B-B14F-4D97-AF65-F5344CB8AC3E}">
+        <p14:creationId xmlns:p14="http://schemas.microsoft.com/office/powerpoint/2010/main" val="456306922"/>
+      </p:ext>
+    </p:extLst>
+  </p:cSld>
+  <p:clrMapOvr>
+    <a:masterClrMapping/>
+  </p:clrMapOvr>
+</p:sld>
+</file>
+
+<file path=ppt/slides/slide5.xml><?xml version="1.0" encoding="utf-8"?>
+<p:sld xmlns:a="http://schemas.openxmlformats.org/drawingml/2006/main" xmlns:r="http://schemas.openxmlformats.org/officeDocument/2006/relationships" xmlns:p="http://schemas.openxmlformats.org/presentationml/2006/main">
+  <p:cSld>
+    <p:spTree>
+      <p:nvGrpSpPr>
+        <p:cNvPr id="1" name="">
+          <a:extLst>
+            <a:ext uri="{FF2B5EF4-FFF2-40B4-BE49-F238E27FC236}">
+              <a16:creationId xmlns:a16="http://schemas.microsoft.com/office/drawing/2014/main" id="{82C13B93-D4F6-EBC5-C0E1-98A5F526F322}"/>
+            </a:ext>
+          </a:extLst>
+        </p:cNvPr>
+        <p:cNvGrpSpPr/>
+        <p:nvPr/>
+      </p:nvGrpSpPr>
+      <p:grpSpPr>
+        <a:xfrm>
+          <a:off x="0" y="0"/>
+          <a:ext cx="0" cy="0"/>
+          <a:chOff x="0" y="0"/>
+          <a:chExt cx="0" cy="0"/>
+        </a:xfrm>
+      </p:grpSpPr>
+      <p:sp>
+        <p:nvSpPr>
+          <p:cNvPr id="2" name="Text Placeholder 1">
+            <a:extLst>
+              <a:ext uri="{FF2B5EF4-FFF2-40B4-BE49-F238E27FC236}">
+                <a16:creationId xmlns:a16="http://schemas.microsoft.com/office/drawing/2014/main" id="{EB080659-6BFC-B019-0802-E733C11577C0}"/>
+              </a:ext>
+            </a:extLst>
+          </p:cNvPr>
+          <p:cNvSpPr>
+            <a:spLocks noGrp="1"/>
+          </p:cNvSpPr>
+          <p:nvPr>
+            <p:ph type="body" sz="quarter" idx="10"/>
+          </p:nvPr>
+        </p:nvSpPr>
+        <p:spPr>
+          <a:xfrm>
+            <a:off x="857250" y="633413"/>
+            <a:ext cx="9139604" cy="554037"/>
+          </a:xfrm>
+        </p:spPr>
+        <p:txBody>
+          <a:bodyPr/>
+          <a:lstStyle/>
+          <a:p>
+            <a:r>
+              <a:rPr lang="en-US" dirty="0"/>
+              <a:t>Day 1 V1</a:t>
+            </a:r>
+          </a:p>
+        </p:txBody>
+      </p:sp>
+      <p:sp>
+        <p:nvSpPr>
+          <p:cNvPr id="3" name="Text Placeholder 2">
+            <a:extLst>
+              <a:ext uri="{FF2B5EF4-FFF2-40B4-BE49-F238E27FC236}">
+                <a16:creationId xmlns:a16="http://schemas.microsoft.com/office/drawing/2014/main" id="{F1A0D069-6B84-A347-4001-4B83EAD8166C}"/>
+              </a:ext>
+            </a:extLst>
+          </p:cNvPr>
+          <p:cNvSpPr>
+            <a:spLocks noGrp="1"/>
+          </p:cNvSpPr>
+          <p:nvPr>
+            <p:ph type="body" sz="quarter" idx="11"/>
+          </p:nvPr>
+        </p:nvSpPr>
+        <p:spPr/>
+        <p:txBody>
+          <a:bodyPr/>
+          <a:lstStyle/>
+          <a:p>
+            <a:pPr marL="571500" indent="-571500">
+              <a:buAutoNum type="romanUcPeriod"/>
+            </a:pPr>
+            <a:r>
+              <a:rPr lang="en-US" b="1" dirty="0"/>
+              <a:t>Core Architecture: Intent Routing &amp; Hybrid Pipeline</a:t>
+            </a:r>
+          </a:p>
+          <a:p>
+            <a:pPr marL="571500" indent="-571500">
+              <a:buFontTx/>
+              <a:buAutoNum type="romanUcPeriod"/>
+            </a:pPr>
+            <a:r>
+              <a:rPr lang="en-US" b="1" dirty="0"/>
+              <a:t>Dialog Strategy: Multi-Turn Scenario Evolution</a:t>
+            </a:r>
+          </a:p>
+          <a:p>
+            <a:pPr marL="571500" indent="-571500">
+              <a:buFontTx/>
+              <a:buAutoNum type="romanUcPeriod"/>
+            </a:pPr>
+            <a:r>
+              <a:rPr lang="en-US" dirty="0"/>
+              <a:t>Self-Evolution: Dynamic Context Programming</a:t>
+            </a:r>
+          </a:p>
+          <a:p>
+            <a:pPr marL="571500" indent="-571500">
+              <a:buFontTx/>
+              <a:buAutoNum type="romanUcPeriod"/>
+            </a:pPr>
+            <a:r>
+              <a:rPr lang="en-US" dirty="0"/>
+              <a:t>Evaluation Matrix: Product &amp; Efficiency Metrics</a:t>
+            </a:r>
+          </a:p>
+          <a:p>
+            <a:pPr marL="571500" indent="-571500">
+              <a:buAutoNum type="romanUcPeriod"/>
+            </a:pPr>
+            <a:endParaRPr lang="en-US" b="1" dirty="0"/>
+          </a:p>
+        </p:txBody>
+      </p:sp>
+    </p:spTree>
+    <p:extLst>
+      <p:ext uri="{BB962C8B-B14F-4D97-AF65-F5344CB8AC3E}">
+        <p14:creationId xmlns:p14="http://schemas.microsoft.com/office/powerpoint/2010/main" val="3840652596"/>
       </p:ext>
     </p:extLst>
   </p:cSld>

</xml_diff>